<commit_message>
Deploying to gh-pages from @ tamanh-oxford/capacity-development@b5da2eb9587165c5ec967d66f332b07b0d69ba83 🚀
</commit_message>
<xml_diff>
--- a/vi/data-frameworks/09-global-landscape-human-resources.pptx
+++ b/vi/data-frameworks/09-global-landscape-human-resources.pptx
@@ -722,7 +722,7 @@
             <a:pPr lvl="0"/>
             <a:r>
               <a:rPr/>
-              <a:t>Các nhóm này hoạt động như</a:t>
+              <a:t>Các nhóm này hoạt động như </a:t>
             </a:r>
             <a:r>
               <a:rPr b="1"/>
@@ -730,7 +730,7 @@
             </a:r>
             <a:r>
               <a:rPr/>
-              <a:t>trong khung quản trị dữ liệu doanh nghiệp.</a:t>
+              <a:t> trong khung quản trị dữ liệu doanh nghiệp.</a:t>
             </a:r>
           </a:p>
           <a:p>
@@ -3988,7 +3988,7 @@
             <a:pPr lvl="0"/>
             <a:r>
               <a:rPr/>
-              <a:t>Thuật ngữ này đề cập đến chủ sở hữu dữ liệu trong kinh doanh, không phải chủ sở hữu hoặc nhà cung cấp hệ thống CNTT.</a:t>
+              <a:t>Thuật ngữ này đề cập đến chủ sở hữu dữ liệu trong kinh doanh, không phải chủ sở hữu hoặc nhà cung cấp hệ thống IT.</a:t>
             </a:r>
           </a:p>
           <a:p>
@@ -4093,7 +4093,7 @@
             <a:pPr lvl="0"/>
             <a:r>
               <a:rPr/>
-              <a:t>Họ thường hợp tác với các kiến trúc sư dữ liệu chuyên môn trong các nhiệm vụ như mô hình hóa dữ liệu và truyền đạt yêu cầu dữ liệu cho các đội ngũ CNTT.</a:t>
+              <a:t>Họ thường hợp tác với các kiến trúc sư dữ liệu chuyên môn trong các nhiệm vụ như mô hình hóa dữ liệu và truyền đạt yêu cầu dữ liệu cho các đội ngũ IT.</a:t>
             </a:r>
           </a:p>
         </p:txBody>
@@ -4163,22 +4163,22 @@
             <a:pPr lvl="0"/>
             <a:r>
               <a:rPr b="1"/>
-              <a:t>Nhânviên chính sách</a:t>
-            </a:r>
-            <a:r>
-              <a:rPr/>
-              <a:t>sử dụng dữ liệu để hỗ trợ phát triển chính sách và ra quyết định.</a:t>
+              <a:t>Nhân viên chính sách</a:t>
+            </a:r>
+            <a:r>
+              <a:rPr/>
+              <a:t> sử dụng dữ liệu để hỗ trợ phát triển chính sách và ra quyết định.</a:t>
             </a:r>
           </a:p>
           <a:p>
             <a:pPr lvl="0"/>
             <a:r>
               <a:rPr b="1"/>
-              <a:t>Các nhàphân tích dữ liệu</a:t>
-            </a:r>
-            <a:r>
-              <a:rPr/>
-              <a:t>phân tích, tích hợp và trực quan hóa dữ liệu để tạo ra các thông tin chi tiết.</a:t>
+              <a:t>Các nhà phân tích dữ liệu</a:t>
+            </a:r>
+            <a:r>
+              <a:rPr/>
+              <a:t> phân tích, tích hợp và trực quan hóa dữ liệu để tạo ra các thông tin chi tiết.</a:t>
             </a:r>
           </a:p>
           <a:p>
@@ -4189,7 +4189,7 @@
             </a:r>
             <a:r>
               <a:rPr/>
-              <a:t>thiết kế mô hình và kiến trúc để quản lý và sử dụng dữ liệu.</a:t>
+              <a:t> thiết kế mô hình và kiến trúc để quản lý và sử dụng dữ liệu.</a:t>
             </a:r>
           </a:p>
           <a:p>
@@ -4200,29 +4200,29 @@
             </a:r>
             <a:r>
               <a:rPr/>
-              <a:t>chịu trách nhiệm làm sạch, tích hợp và chuẩn bị dữ liệu cho phân tích, đồng thời hỗ trợ xác định kiến trúc dữ liệu.</a:t>
+              <a:t> chịu trách nhiệm làm sạch, tích hợp và chuẩn bị dữ liệu cho phân tích, đồng thời hỗ trợ xác định kiến trúc dữ liệu.</a:t>
             </a:r>
           </a:p>
           <a:p>
             <a:pPr lvl="0"/>
             <a:r>
               <a:rPr b="1"/>
-              <a:t>Nhàkhoa học dữ liệu</a:t>
-            </a:r>
-            <a:r>
-              <a:rPr/>
-              <a:t>phân tích các tập dữ liệu lớn bằng thống kê, phân tích nâng cao, học máy và trí tuệ nhân tạo để xác định các mẫu và thông tin chi tiết.</a:t>
+              <a:t>Nhà khoa học dữ liệu</a:t>
+            </a:r>
+            <a:r>
+              <a:rPr/>
+              <a:t> phân tích các tập dữ liệu lớn bằng thống kê, phân tích nâng cao, học máy và trí tuệ nhân tạo để xác định các mẫu và thông tin chi tiết.</a:t>
             </a:r>
           </a:p>
           <a:p>
             <a:pPr lvl="0"/>
             <a:r>
               <a:rPr b="1"/>
-              <a:t>Nhânviên</a:t>
-            </a:r>
-            <a:r>
-              <a:rPr/>
-              <a:t>phát triển</a:t>
+              <a:t>Nhân viên</a:t>
+            </a:r>
+            <a:r>
+              <a:rPr/>
+              <a:t> phát triển </a:t>
             </a:r>
             <a:r>
               <a:rPr b="1"/>
@@ -4230,7 +4230,7 @@
             </a:r>
             <a:r>
               <a:rPr/>
-              <a:t>xây dựng các đường ống dữ liệu, triển khai kiến trúc dữ liệu, tạo giao diện truy cập dữ liệu và tích hợp chính sách dữ liệu vào hệ thống CNTT.</a:t>
+              <a:t> xây dựng các đường ống dữ liệu, triển khai kiến trúc dữ liệu, tạo giao diện truy cập dữ liệu và tích hợp chính sách dữ liệu vào hệ thống IT.</a:t>
             </a:r>
           </a:p>
         </p:txBody>

</xml_diff>